<commit_message>
Fix slide 3 — actual fee structure was still showing old June 10 pricing
</commit_message>
<xml_diff>
--- a/eMagazines_Transition_TLDR_3.pptx
+++ b/eMagazines_Transition_TLDR_3.pptx
@@ -4082,7 +4082,7 @@
                 <a:ea typeface="Calibri" pitchFamily="34" charset="-122"/>
                 <a:cs typeface="Calibri" pitchFamily="34" charset="-120"/>
               </a:rPr>
-              <a:t>What they're offering · June 10, 2026 proposal · 60-day validity</a:t>
+              <a:t>What they're offering · June 17, 2026 proposal · 60-day validity</a:t>
             </a:r>
             <a:endParaRPr lang="en-US" sz="1000" dirty="0"/>
           </a:p>
@@ -5013,7 +5013,7 @@
                 <a:ea typeface="Calibri" pitchFamily="34" charset="-122"/>
                 <a:cs typeface="Calibri" pitchFamily="34" charset="-120"/>
               </a:rPr>
-              <a:t>$350/brand/mo</a:t>
+              <a:t>$300/brand/mo</a:t>
             </a:r>
             <a:endParaRPr lang="en-US" sz="950" dirty="0"/>
           </a:p>
@@ -5121,7 +5121,7 @@
                 <a:ea typeface="Calibri" pitchFamily="34" charset="-122"/>
                 <a:cs typeface="Calibri" pitchFamily="34" charset="-120"/>
               </a:rPr>
-              <a:t>$300/brand/mo</a:t>
+              <a:t>$275/brand/mo</a:t>
             </a:r>
             <a:endParaRPr lang="en-US" sz="950" dirty="0"/>
           </a:p>
@@ -5376,7 +5376,7 @@
                 <a:ea typeface="Calibri" pitchFamily="34" charset="-122"/>
                 <a:cs typeface="Calibri" pitchFamily="34" charset="-120"/>
               </a:rPr>
-              <a:t>$150/issue</a:t>
+              <a:t>$125/issue</a:t>
             </a:r>
             <a:endParaRPr lang="en-US" sz="950" dirty="0"/>
           </a:p>
@@ -5484,7 +5484,7 @@
                 <a:ea typeface="Calibri" pitchFamily="34" charset="-122"/>
                 <a:cs typeface="Calibri" pitchFamily="34" charset="-120"/>
               </a:rPr>
-              <a:t>$250/issue</a:t>
+              <a:t>$200/issue</a:t>
             </a:r>
             <a:endParaRPr lang="en-US" sz="950" dirty="0"/>
           </a:p>
@@ -5886,7 +5886,7 @@
                 <a:ea typeface="Calibri" pitchFamily="34" charset="-122"/>
                 <a:cs typeface="Calibri" pitchFamily="34" charset="-120"/>
               </a:rPr>
-              <a:t>$550</a:t>
+              <a:t>$250</a:t>
             </a:r>
             <a:endParaRPr lang="en-US" sz="950" dirty="0"/>
           </a:p>

</xml_diff>